<commit_message>
feat: update placeholder replacement logic
</commit_message>
<xml_diff>
--- a/backend/Cherry.Api/Storage/templates/standard_v1.pptx
+++ b/backend/Cherry.Api/Storage/templates/standard_v1.pptx
@@ -3398,6 +3398,12 @@
         <p:txBody>
           <a:bodyPr/>
           <a:p>
+            <a:r>
+              <a:rPr lang="en-US" altLang="en-US">
+                <a:sym typeface="+mn-ea"/>
+              </a:rPr>
+              <a:t>{{section.Executive_Summary.0.title}}</a:t>
+            </a:r>
             <a:endParaRPr lang="en-US"/>
           </a:p>
         </p:txBody>
@@ -3418,7 +3424,7 @@
           <a:p>
             <a:r>
               <a:rPr lang="en-US" altLang="en-US"/>
-              <a:t>{{section.Executive_Summary.content}}</a:t>
+              <a:t>{{section.Executive_Summary.0.content}}</a:t>
             </a:r>
             <a:endParaRPr lang="en-US" altLang="en-US"/>
           </a:p>
@@ -3965,6 +3971,25 @@
 </file>
 
 <file path=customXml/item1.xml><?xml version="1.0" encoding="utf-8"?>
+<?mso-contentType ?>
+<FormTemplates xmlns="http://schemas.microsoft.com/sharepoint/v3/contenttype/forms">
+  <Display>DocumentLibraryForm</Display>
+  <Edit>DocumentLibraryForm</Edit>
+  <New>DocumentLibraryForm</New>
+</FormTemplates>
+</file>
+
+<file path=customXml/item2.xml><?xml version="1.0" encoding="utf-8"?>
+<p:properties xmlns:p="http://schemas.microsoft.com/office/2006/metadata/properties" xmlns:xsi="http://www.w3.org/2001/XMLSchema-instance" xmlns:pc="http://schemas.microsoft.com/office/infopath/2007/PartnerControls">
+  <documentManagement>
+    <consider xmlns="8b1adfb4-9367-40a2-9f2d-f39317b7f046">true</consider>
+    <Tag xmlns="8b1adfb4-9367-40a2-9f2d-f39317b7f046" xsi:nil="true"/>
+    <Date xmlns="8b1adfb4-9367-40a2-9f2d-f39317b7f046" xsi:nil="true"/>
+  </documentManagement>
+</p:properties>
+</file>
+
+<file path=customXml/item3.xml><?xml version="1.0" encoding="utf-8"?>
 <ct:contentTypeSchema xmlns:ct="http://schemas.microsoft.com/office/2006/metadata/contentType" xmlns:ma="http://schemas.microsoft.com/office/2006/metadata/properties/metaAttributes" ct:_="" ma:_="" ma:contentTypeName="Document" ma:contentTypeID="0x010100D34F63D4E2FFAC4B999DE4DD6FD9F2CD" ma:contentTypeVersion="10" ma:contentTypeDescription="Create a new document." ma:contentTypeScope="" ma:versionID="a3cced944925c255e524f5f7c45a214b">
   <xsd:schema xmlns:xsd="http://www.w3.org/2001/XMLSchema" xmlns:xs="http://www.w3.org/2001/XMLSchema" xmlns:p="http://schemas.microsoft.com/office/2006/metadata/properties" xmlns:ns2="c430b873-7b30-4fba-a176-07ee339e2108" xmlns:ns3="8b1adfb4-9367-40a2-9f2d-f39317b7f046" targetNamespace="http://schemas.microsoft.com/office/2006/metadata/properties" ma:root="true" ma:fieldsID="8749b68dee70fcea35a6fe2635ebcf3b" ns2:_="" ns3:_="">
     <xsd:import namespace="c430b873-7b30-4fba-a176-07ee339e2108"/>
@@ -4167,39 +4192,20 @@
 </ct:contentTypeSchema>
 </file>
 
-<file path=customXml/item2.xml><?xml version="1.0" encoding="utf-8"?>
-<?mso-contentType ?>
-<FormTemplates xmlns="http://schemas.microsoft.com/sharepoint/v3/contenttype/forms">
-  <Display>DocumentLibraryForm</Display>
-  <Edit>DocumentLibraryForm</Edit>
-  <New>DocumentLibraryForm</New>
-</FormTemplates>
-</file>
-
-<file path=customXml/item3.xml><?xml version="1.0" encoding="utf-8"?>
-<p:properties xmlns:p="http://schemas.microsoft.com/office/2006/metadata/properties" xmlns:xsi="http://www.w3.org/2001/XMLSchema-instance" xmlns:pc="http://schemas.microsoft.com/office/infopath/2007/PartnerControls">
-  <documentManagement>
-    <consider xmlns="8b1adfb4-9367-40a2-9f2d-f39317b7f046">true</consider>
-    <Tag xmlns="8b1adfb4-9367-40a2-9f2d-f39317b7f046" xsi:nil="true"/>
-    <Date xmlns="8b1adfb4-9367-40a2-9f2d-f39317b7f046" xsi:nil="true"/>
-  </documentManagement>
-</p:properties>
-</file>
-
 <file path=customXml/itemProps1.xml><?xml version="1.0" encoding="utf-8"?>
-<ds:datastoreItem xmlns:ds="http://schemas.openxmlformats.org/officeDocument/2006/customXml" ds:itemID="{1E8B99EC-ED63-46B3-9751-B374478A2AE2}">
+<ds:datastoreItem xmlns:ds="http://schemas.openxmlformats.org/officeDocument/2006/customXml" ds:itemID="{569B4871-4362-42CF-BE0E-8F3D1941609A}">
   <ds:schemaRefs/>
 </ds:datastoreItem>
 </file>
 
 <file path=customXml/itemProps2.xml><?xml version="1.0" encoding="utf-8"?>
-<ds:datastoreItem xmlns:ds="http://schemas.openxmlformats.org/officeDocument/2006/customXml" ds:itemID="{569B4871-4362-42CF-BE0E-8F3D1941609A}">
+<ds:datastoreItem xmlns:ds="http://schemas.openxmlformats.org/officeDocument/2006/customXml" ds:itemID="{EB2E7C00-A1F5-470F-829D-A0F53DF17FE2}">
   <ds:schemaRefs/>
 </ds:datastoreItem>
 </file>
 
 <file path=customXml/itemProps3.xml><?xml version="1.0" encoding="utf-8"?>
-<ds:datastoreItem xmlns:ds="http://schemas.openxmlformats.org/officeDocument/2006/customXml" ds:itemID="{EB2E7C00-A1F5-470F-829D-A0F53DF17FE2}">
+<ds:datastoreItem xmlns:ds="http://schemas.openxmlformats.org/officeDocument/2006/customXml" ds:itemID="{1E8B99EC-ED63-46B3-9751-B374478A2AE2}">
   <ds:schemaRefs/>
 </ds:datastoreItem>
 </file>
</xml_diff>